<commit_message>
Comparables table compiled in LaTeX, narrower sample table B1
Co-Authored-By: Claude Fable 5 <noreply@anthropic.com>
Claude-Session: https://claude.ai/code/session_01DNzQPDcr3zfLTraMHUHqUn
</commit_message>
<xml_diff>
--- a/report/data_cluster/comparables_slides.pptx
+++ b/report/data_cluster/comparables_slides.pptx
@@ -6,7 +6,6 @@
   </p:sldMasterIdLst>
   <p:sldIdLst>
     <p:sldId id="256" r:id="rId7"/>
-    <p:sldId id="257" r:id="rId8"/>
   </p:sldIdLst>
   <p:sldSz cx="12191695" cy="6858000" type="screen4x3"/>
   <p:notesSz cx="6858000" cy="9144000"/>
@@ -3097,8 +3096,8 @@
         </p:nvSpPr>
         <p:spPr>
           <a:xfrm>
-            <a:off x="502920" y="219456"/>
-            <a:ext cx="11247120" cy="566928"/>
+            <a:off x="502920" y="182880"/>
+            <a:ext cx="11247120" cy="502920"/>
           </a:xfrm>
           <a:prstGeom prst="rect">
             <a:avLst/>
@@ -3106,1840 +3105,26 @@
           <a:noFill/>
         </p:spPr>
         <p:txBody>
-          <a:bodyPr wrap="square" lIns="0" rIns="0" tIns="0" bIns="0">
+          <a:bodyPr wrap="none">
             <a:spAutoFit/>
           </a:bodyPr>
           <a:lstStyle/>
           <a:p>
-            <a:pPr algn="l">
-              <a:lnSpc>
-                <a:spcPts val="3584"/>
-              </a:lnSpc>
-            </a:pPr>
-            <a:r>
-              <a:rPr sz="2800" b="1" i="0">
+            <a:r>
+              <a:rPr sz="2600" b="1">
                 <a:solidFill>
                   <a:srgbClr val="102D5E"/>
                 </a:solidFill>
                 <a:latin typeface="Garamond"/>
               </a:rPr>
-              <a:t>Comparable professions: who we compare teachers with</a:t>
-            </a:r>
-          </a:p>
-        </p:txBody>
-      </p:sp>
-      <p:cxnSp>
-        <p:nvCxnSpPr>
-          <p:cNvPr id="3" name="Connector 2"/>
-          <p:cNvCxnSpPr/>
-          <p:nvPr/>
-        </p:nvCxnSpPr>
-        <p:spPr>
-          <a:xfrm>
-            <a:off x="822960" y="1417320"/>
-            <a:ext cx="10698480" cy="0"/>
-          </a:xfrm>
-          <a:prstGeom prst="line">
-            <a:avLst/>
-          </a:prstGeom>
-          <a:ln w="16510">
-            <a:solidFill>
-              <a:srgbClr val="212529"/>
-            </a:solidFill>
-          </a:ln>
-          <a:effectLst/>
-        </p:spPr>
-        <p:style>
-          <a:lnRef idx="2">
-            <a:schemeClr val="accent1"/>
-          </a:lnRef>
-          <a:fillRef idx="0">
-            <a:schemeClr val="accent1"/>
-          </a:fillRef>
-          <a:effectRef idx="1">
-            <a:schemeClr val="accent1"/>
-          </a:effectRef>
-          <a:fontRef idx="minor">
-            <a:schemeClr val="tx1"/>
-          </a:fontRef>
-        </p:style>
-      </p:cxnSp>
-      <p:sp>
-        <p:nvSpPr>
-          <p:cNvPr id="4" name="TextBox 3"/>
-          <p:cNvSpPr txBox="1"/>
-          <p:nvPr/>
-        </p:nvSpPr>
-        <p:spPr>
-          <a:xfrm>
-            <a:off x="4663440" y="1527048"/>
-            <a:ext cx="1645920" cy="365760"/>
-          </a:xfrm>
-          <a:prstGeom prst="rect">
-            <a:avLst/>
-          </a:prstGeom>
-          <a:noFill/>
-        </p:spPr>
-        <p:txBody>
-          <a:bodyPr wrap="square" lIns="0" rIns="0" tIns="0" bIns="0">
-            <a:spAutoFit/>
-          </a:bodyPr>
-          <a:lstStyle/>
-          <a:p>
-            <a:pPr algn="r">
-              <a:lnSpc>
-                <a:spcPts val="1920"/>
-              </a:lnSpc>
-            </a:pPr>
-            <a:r>
-              <a:rPr sz="1500" b="1" i="0">
-                <a:solidFill>
-                  <a:srgbClr val="212529"/>
-                </a:solidFill>
-                <a:latin typeface="Garamond"/>
-              </a:rPr>
-              <a:t>Teachers</a:t>
-            </a:r>
-          </a:p>
-        </p:txBody>
-      </p:sp>
-      <p:sp>
-        <p:nvSpPr>
-          <p:cNvPr id="5" name="TextBox 4"/>
-          <p:cNvSpPr txBox="1"/>
-          <p:nvPr/>
-        </p:nvSpPr>
-        <p:spPr>
-          <a:xfrm>
-            <a:off x="6400800" y="1527048"/>
-            <a:ext cx="1645920" cy="365760"/>
-          </a:xfrm>
-          <a:prstGeom prst="rect">
-            <a:avLst/>
-          </a:prstGeom>
-          <a:noFill/>
-        </p:spPr>
-        <p:txBody>
-          <a:bodyPr wrap="square" lIns="0" rIns="0" tIns="0" bIns="0">
-            <a:spAutoFit/>
-          </a:bodyPr>
-          <a:lstStyle/>
-          <a:p>
-            <a:pPr algn="r">
-              <a:lnSpc>
-                <a:spcPts val="1920"/>
-              </a:lnSpc>
-            </a:pPr>
-            <a:r>
-              <a:rPr sz="1500" b="1" i="0">
-                <a:solidFill>
-                  <a:srgbClr val="212529"/>
-                </a:solidFill>
-                <a:latin typeface="Garamond"/>
-              </a:rPr>
-              <a:t>Nurses</a:t>
-            </a:r>
-          </a:p>
-        </p:txBody>
-      </p:sp>
-      <p:sp>
-        <p:nvSpPr>
-          <p:cNvPr id="6" name="TextBox 5"/>
-          <p:cNvSpPr txBox="1"/>
-          <p:nvPr/>
-        </p:nvSpPr>
-        <p:spPr>
-          <a:xfrm>
-            <a:off x="8138160" y="1527048"/>
-            <a:ext cx="1737360" cy="365760"/>
-          </a:xfrm>
-          <a:prstGeom prst="rect">
-            <a:avLst/>
-          </a:prstGeom>
-          <a:noFill/>
-        </p:spPr>
-        <p:txBody>
-          <a:bodyPr wrap="square" lIns="0" rIns="0" tIns="0" bIns="0">
-            <a:spAutoFit/>
-          </a:bodyPr>
-          <a:lstStyle/>
-          <a:p>
-            <a:pPr algn="r">
-              <a:lnSpc>
-                <a:spcPts val="1920"/>
-              </a:lnSpc>
-            </a:pPr>
-            <a:r>
-              <a:rPr sz="1500" b="1" i="0">
-                <a:solidFill>
-                  <a:srgbClr val="212529"/>
-                </a:solidFill>
-                <a:latin typeface="Garamond"/>
-              </a:rPr>
-              <a:t>Social workers</a:t>
-            </a:r>
-          </a:p>
-        </p:txBody>
-      </p:sp>
-      <p:sp>
-        <p:nvSpPr>
-          <p:cNvPr id="7" name="TextBox 6"/>
-          <p:cNvSpPr txBox="1"/>
-          <p:nvPr/>
-        </p:nvSpPr>
-        <p:spPr>
-          <a:xfrm>
-            <a:off x="9966960" y="1527048"/>
-            <a:ext cx="1554480" cy="365760"/>
-          </a:xfrm>
-          <a:prstGeom prst="rect">
-            <a:avLst/>
-          </a:prstGeom>
-          <a:noFill/>
-        </p:spPr>
-        <p:txBody>
-          <a:bodyPr wrap="square" lIns="0" rIns="0" tIns="0" bIns="0">
-            <a:spAutoFit/>
-          </a:bodyPr>
-          <a:lstStyle/>
-          <a:p>
-            <a:pPr algn="r">
-              <a:lnSpc>
-                <a:spcPts val="1920"/>
-              </a:lnSpc>
-            </a:pPr>
-            <a:r>
-              <a:rPr sz="1500" b="1" i="0">
-                <a:solidFill>
-                  <a:srgbClr val="212529"/>
-                </a:solidFill>
-                <a:latin typeface="Garamond"/>
-              </a:rPr>
-              <a:t>Counselors</a:t>
-            </a:r>
-          </a:p>
-        </p:txBody>
-      </p:sp>
-      <p:cxnSp>
-        <p:nvCxnSpPr>
-          <p:cNvPr id="8" name="Connector 7"/>
-          <p:cNvCxnSpPr/>
-          <p:nvPr/>
-        </p:nvCxnSpPr>
-        <p:spPr>
-          <a:xfrm>
-            <a:off x="822960" y="1911095"/>
-            <a:ext cx="10698480" cy="0"/>
-          </a:xfrm>
-          <a:prstGeom prst="line">
-            <a:avLst/>
-          </a:prstGeom>
-          <a:ln w="8890">
-            <a:solidFill>
-              <a:srgbClr val="212529"/>
-            </a:solidFill>
-          </a:ln>
-          <a:effectLst/>
-        </p:spPr>
-        <p:style>
-          <a:lnRef idx="2">
-            <a:schemeClr val="accent1"/>
-          </a:lnRef>
-          <a:fillRef idx="0">
-            <a:schemeClr val="accent1"/>
-          </a:fillRef>
-          <a:effectRef idx="1">
-            <a:schemeClr val="accent1"/>
-          </a:effectRef>
-          <a:fontRef idx="minor">
-            <a:schemeClr val="tx1"/>
-          </a:fontRef>
-        </p:style>
-      </p:cxnSp>
-      <p:sp>
-        <p:nvSpPr>
-          <p:cNvPr id="9" name="TextBox 8"/>
-          <p:cNvSpPr txBox="1"/>
-          <p:nvPr/>
-        </p:nvSpPr>
-        <p:spPr>
-          <a:xfrm>
-            <a:off x="822960" y="2020824"/>
-            <a:ext cx="3657600" cy="365760"/>
-          </a:xfrm>
-          <a:prstGeom prst="rect">
-            <a:avLst/>
-          </a:prstGeom>
-          <a:noFill/>
-        </p:spPr>
-        <p:txBody>
-          <a:bodyPr wrap="square" lIns="0" rIns="0" tIns="0" bIns="0">
-            <a:spAutoFit/>
-          </a:bodyPr>
-          <a:lstStyle/>
-          <a:p>
-            <a:pPr algn="l">
-              <a:lnSpc>
-                <a:spcPts val="1920"/>
-              </a:lnSpc>
-            </a:pPr>
-            <a:r>
-              <a:rPr sz="1500" b="0" i="0">
-                <a:solidFill>
-                  <a:srgbClr val="212529"/>
-                </a:solidFill>
-                <a:latin typeface="Garamond"/>
-              </a:rPr>
-              <a:t>Female (%)</a:t>
-            </a:r>
-          </a:p>
-        </p:txBody>
-      </p:sp>
-      <p:sp>
-        <p:nvSpPr>
-          <p:cNvPr id="10" name="TextBox 9"/>
-          <p:cNvSpPr txBox="1"/>
-          <p:nvPr/>
-        </p:nvSpPr>
-        <p:spPr>
-          <a:xfrm>
-            <a:off x="4663440" y="2020824"/>
-            <a:ext cx="1645920" cy="365760"/>
-          </a:xfrm>
-          <a:prstGeom prst="rect">
-            <a:avLst/>
-          </a:prstGeom>
-          <a:noFill/>
-        </p:spPr>
-        <p:txBody>
-          <a:bodyPr wrap="square" lIns="0" rIns="0" tIns="0" bIns="0">
-            <a:spAutoFit/>
-          </a:bodyPr>
-          <a:lstStyle/>
-          <a:p>
-            <a:pPr algn="r">
-              <a:lnSpc>
-                <a:spcPts val="1920"/>
-              </a:lnSpc>
-            </a:pPr>
-            <a:r>
-              <a:rPr sz="1500" b="0" i="0">
-                <a:solidFill>
-                  <a:srgbClr val="212529"/>
-                </a:solidFill>
-                <a:latin typeface="Garamond"/>
-              </a:rPr>
-              <a:t>76.0</a:t>
-            </a:r>
-          </a:p>
-        </p:txBody>
-      </p:sp>
-      <p:sp>
-        <p:nvSpPr>
-          <p:cNvPr id="11" name="TextBox 10"/>
-          <p:cNvSpPr txBox="1"/>
-          <p:nvPr/>
-        </p:nvSpPr>
-        <p:spPr>
-          <a:xfrm>
-            <a:off x="6400800" y="2020824"/>
-            <a:ext cx="1645920" cy="365760"/>
-          </a:xfrm>
-          <a:prstGeom prst="rect">
-            <a:avLst/>
-          </a:prstGeom>
-          <a:noFill/>
-        </p:spPr>
-        <p:txBody>
-          <a:bodyPr wrap="square" lIns="0" rIns="0" tIns="0" bIns="0">
-            <a:spAutoFit/>
-          </a:bodyPr>
-          <a:lstStyle/>
-          <a:p>
-            <a:pPr algn="r">
-              <a:lnSpc>
-                <a:spcPts val="1920"/>
-              </a:lnSpc>
-            </a:pPr>
-            <a:r>
-              <a:rPr sz="1500" b="0" i="0">
-                <a:solidFill>
-                  <a:srgbClr val="212529"/>
-                </a:solidFill>
-                <a:latin typeface="Garamond"/>
-              </a:rPr>
-              <a:t>88.2</a:t>
-            </a:r>
-          </a:p>
-        </p:txBody>
-      </p:sp>
-      <p:sp>
-        <p:nvSpPr>
-          <p:cNvPr id="12" name="TextBox 11"/>
-          <p:cNvSpPr txBox="1"/>
-          <p:nvPr/>
-        </p:nvSpPr>
-        <p:spPr>
-          <a:xfrm>
-            <a:off x="8138160" y="2020824"/>
-            <a:ext cx="1737360" cy="365760"/>
-          </a:xfrm>
-          <a:prstGeom prst="rect">
-            <a:avLst/>
-          </a:prstGeom>
-          <a:noFill/>
-        </p:spPr>
-        <p:txBody>
-          <a:bodyPr wrap="square" lIns="0" rIns="0" tIns="0" bIns="0">
-            <a:spAutoFit/>
-          </a:bodyPr>
-          <a:lstStyle/>
-          <a:p>
-            <a:pPr algn="r">
-              <a:lnSpc>
-                <a:spcPts val="1920"/>
-              </a:lnSpc>
-            </a:pPr>
-            <a:r>
-              <a:rPr sz="1500" b="0" i="0">
-                <a:solidFill>
-                  <a:srgbClr val="212529"/>
-                </a:solidFill>
-                <a:latin typeface="Garamond"/>
-              </a:rPr>
-              <a:t>82.9</a:t>
-            </a:r>
-          </a:p>
-        </p:txBody>
-      </p:sp>
-      <p:sp>
-        <p:nvSpPr>
-          <p:cNvPr id="13" name="TextBox 12"/>
-          <p:cNvSpPr txBox="1"/>
-          <p:nvPr/>
-        </p:nvSpPr>
-        <p:spPr>
-          <a:xfrm>
-            <a:off x="9966960" y="2020824"/>
-            <a:ext cx="1554480" cy="365760"/>
-          </a:xfrm>
-          <a:prstGeom prst="rect">
-            <a:avLst/>
-          </a:prstGeom>
-          <a:noFill/>
-        </p:spPr>
-        <p:txBody>
-          <a:bodyPr wrap="square" lIns="0" rIns="0" tIns="0" bIns="0">
-            <a:spAutoFit/>
-          </a:bodyPr>
-          <a:lstStyle/>
-          <a:p>
-            <a:pPr algn="r">
-              <a:lnSpc>
-                <a:spcPts val="1920"/>
-              </a:lnSpc>
-            </a:pPr>
-            <a:r>
-              <a:rPr sz="1500" b="0" i="0">
-                <a:solidFill>
-                  <a:srgbClr val="212529"/>
-                </a:solidFill>
-                <a:latin typeface="Garamond"/>
-              </a:rPr>
-              <a:t>76.2</a:t>
-            </a:r>
-          </a:p>
-        </p:txBody>
-      </p:sp>
-      <p:sp>
-        <p:nvSpPr>
-          <p:cNvPr id="14" name="TextBox 13"/>
-          <p:cNvSpPr txBox="1"/>
-          <p:nvPr/>
-        </p:nvSpPr>
-        <p:spPr>
-          <a:xfrm>
-            <a:off x="822960" y="2386584"/>
-            <a:ext cx="3657600" cy="365760"/>
-          </a:xfrm>
-          <a:prstGeom prst="rect">
-            <a:avLst/>
-          </a:prstGeom>
-          <a:noFill/>
-        </p:spPr>
-        <p:txBody>
-          <a:bodyPr wrap="square" lIns="0" rIns="0" tIns="0" bIns="0">
-            <a:spAutoFit/>
-          </a:bodyPr>
-          <a:lstStyle/>
-          <a:p>
-            <a:pPr algn="l">
-              <a:lnSpc>
-                <a:spcPts val="1920"/>
-              </a:lnSpc>
-            </a:pPr>
-            <a:r>
-              <a:rPr sz="1500" b="0" i="0">
-                <a:solidFill>
-                  <a:srgbClr val="212529"/>
-                </a:solidFill>
-                <a:latin typeface="Garamond"/>
-              </a:rPr>
-              <a:t>Average age (years)</a:t>
-            </a:r>
-          </a:p>
-        </p:txBody>
-      </p:sp>
-      <p:sp>
-        <p:nvSpPr>
-          <p:cNvPr id="15" name="TextBox 14"/>
-          <p:cNvSpPr txBox="1"/>
-          <p:nvPr/>
-        </p:nvSpPr>
-        <p:spPr>
-          <a:xfrm>
-            <a:off x="4663440" y="2386584"/>
-            <a:ext cx="1645920" cy="365760"/>
-          </a:xfrm>
-          <a:prstGeom prst="rect">
-            <a:avLst/>
-          </a:prstGeom>
-          <a:noFill/>
-        </p:spPr>
-        <p:txBody>
-          <a:bodyPr wrap="square" lIns="0" rIns="0" tIns="0" bIns="0">
-            <a:spAutoFit/>
-          </a:bodyPr>
-          <a:lstStyle/>
-          <a:p>
-            <a:pPr algn="r">
-              <a:lnSpc>
-                <a:spcPts val="1920"/>
-              </a:lnSpc>
-            </a:pPr>
-            <a:r>
-              <a:rPr sz="1500" b="0" i="0">
-                <a:solidFill>
-                  <a:srgbClr val="212529"/>
-                </a:solidFill>
-                <a:latin typeface="Garamond"/>
-              </a:rPr>
-              <a:t>44.4</a:t>
-            </a:r>
-          </a:p>
-        </p:txBody>
-      </p:sp>
-      <p:sp>
-        <p:nvSpPr>
-          <p:cNvPr id="16" name="TextBox 15"/>
-          <p:cNvSpPr txBox="1"/>
-          <p:nvPr/>
-        </p:nvSpPr>
-        <p:spPr>
-          <a:xfrm>
-            <a:off x="6400800" y="2386584"/>
-            <a:ext cx="1645920" cy="365760"/>
-          </a:xfrm>
-          <a:prstGeom prst="rect">
-            <a:avLst/>
-          </a:prstGeom>
-          <a:noFill/>
-        </p:spPr>
-        <p:txBody>
-          <a:bodyPr wrap="square" lIns="0" rIns="0" tIns="0" bIns="0">
-            <a:spAutoFit/>
-          </a:bodyPr>
-          <a:lstStyle/>
-          <a:p>
-            <a:pPr algn="r">
-              <a:lnSpc>
-                <a:spcPts val="1920"/>
-              </a:lnSpc>
-            </a:pPr>
-            <a:r>
-              <a:rPr sz="1500" b="0" i="0">
-                <a:solidFill>
-                  <a:srgbClr val="212529"/>
-                </a:solidFill>
-                <a:latin typeface="Garamond"/>
-              </a:rPr>
-              <a:t>43.1</a:t>
-            </a:r>
-          </a:p>
-        </p:txBody>
-      </p:sp>
-      <p:sp>
-        <p:nvSpPr>
-          <p:cNvPr id="17" name="TextBox 16"/>
-          <p:cNvSpPr txBox="1"/>
-          <p:nvPr/>
-        </p:nvSpPr>
-        <p:spPr>
-          <a:xfrm>
-            <a:off x="8138160" y="2386584"/>
-            <a:ext cx="1737360" cy="365760"/>
-          </a:xfrm>
-          <a:prstGeom prst="rect">
-            <a:avLst/>
-          </a:prstGeom>
-          <a:noFill/>
-        </p:spPr>
-        <p:txBody>
-          <a:bodyPr wrap="square" lIns="0" rIns="0" tIns="0" bIns="0">
-            <a:spAutoFit/>
-          </a:bodyPr>
-          <a:lstStyle/>
-          <a:p>
-            <a:pPr algn="r">
-              <a:lnSpc>
-                <a:spcPts val="1920"/>
-              </a:lnSpc>
-            </a:pPr>
-            <a:r>
-              <a:rPr sz="1500" b="0" i="0">
-                <a:solidFill>
-                  <a:srgbClr val="212529"/>
-                </a:solidFill>
-                <a:latin typeface="Garamond"/>
-              </a:rPr>
-              <a:t>43.4</a:t>
-            </a:r>
-          </a:p>
-        </p:txBody>
-      </p:sp>
-      <p:sp>
-        <p:nvSpPr>
-          <p:cNvPr id="18" name="TextBox 17"/>
-          <p:cNvSpPr txBox="1"/>
-          <p:nvPr/>
-        </p:nvSpPr>
-        <p:spPr>
-          <a:xfrm>
-            <a:off x="9966960" y="2386584"/>
-            <a:ext cx="1554480" cy="365760"/>
-          </a:xfrm>
-          <a:prstGeom prst="rect">
-            <a:avLst/>
-          </a:prstGeom>
-          <a:noFill/>
-        </p:spPr>
-        <p:txBody>
-          <a:bodyPr wrap="square" lIns="0" rIns="0" tIns="0" bIns="0">
-            <a:spAutoFit/>
-          </a:bodyPr>
-          <a:lstStyle/>
-          <a:p>
-            <a:pPr algn="r">
-              <a:lnSpc>
-                <a:spcPts val="1920"/>
-              </a:lnSpc>
-            </a:pPr>
-            <a:r>
-              <a:rPr sz="1500" b="0" i="0">
-                <a:solidFill>
-                  <a:srgbClr val="212529"/>
-                </a:solidFill>
-                <a:latin typeface="Garamond"/>
-              </a:rPr>
-              <a:t>43.2</a:t>
-            </a:r>
-          </a:p>
-        </p:txBody>
-      </p:sp>
-      <p:sp>
-        <p:nvSpPr>
-          <p:cNvPr id="19" name="TextBox 18"/>
-          <p:cNvSpPr txBox="1"/>
-          <p:nvPr/>
-        </p:nvSpPr>
-        <p:spPr>
-          <a:xfrm>
-            <a:off x="822960" y="2752344"/>
-            <a:ext cx="3657600" cy="365760"/>
-          </a:xfrm>
-          <a:prstGeom prst="rect">
-            <a:avLst/>
-          </a:prstGeom>
-          <a:noFill/>
-        </p:spPr>
-        <p:txBody>
-          <a:bodyPr wrap="square" lIns="0" rIns="0" tIns="0" bIns="0">
-            <a:spAutoFit/>
-          </a:bodyPr>
-          <a:lstStyle/>
-          <a:p>
-            <a:pPr algn="l">
-              <a:lnSpc>
-                <a:spcPts val="1920"/>
-              </a:lnSpc>
-            </a:pPr>
-            <a:r>
-              <a:rPr sz="1500" b="0" i="0">
-                <a:solidFill>
-                  <a:srgbClr val="212529"/>
-                </a:solidFill>
-                <a:latin typeface="Garamond"/>
-              </a:rPr>
-              <a:t>Master’s or higher (%)</a:t>
-            </a:r>
-          </a:p>
-        </p:txBody>
-      </p:sp>
-      <p:sp>
-        <p:nvSpPr>
-          <p:cNvPr id="20" name="TextBox 19"/>
-          <p:cNvSpPr txBox="1"/>
-          <p:nvPr/>
-        </p:nvSpPr>
-        <p:spPr>
-          <a:xfrm>
-            <a:off x="4663440" y="2752344"/>
-            <a:ext cx="1645920" cy="365760"/>
-          </a:xfrm>
-          <a:prstGeom prst="rect">
-            <a:avLst/>
-          </a:prstGeom>
-          <a:noFill/>
-        </p:spPr>
-        <p:txBody>
-          <a:bodyPr wrap="square" lIns="0" rIns="0" tIns="0" bIns="0">
-            <a:spAutoFit/>
-          </a:bodyPr>
-          <a:lstStyle/>
-          <a:p>
-            <a:pPr algn="r">
-              <a:lnSpc>
-                <a:spcPts val="1920"/>
-              </a:lnSpc>
-            </a:pPr>
-            <a:r>
-              <a:rPr sz="1500" b="0" i="0">
-                <a:solidFill>
-                  <a:srgbClr val="212529"/>
-                </a:solidFill>
-                <a:latin typeface="Garamond"/>
-              </a:rPr>
-              <a:t>51.9</a:t>
-            </a:r>
-          </a:p>
-        </p:txBody>
-      </p:sp>
-      <p:sp>
-        <p:nvSpPr>
-          <p:cNvPr id="21" name="TextBox 20"/>
-          <p:cNvSpPr txBox="1"/>
-          <p:nvPr/>
-        </p:nvSpPr>
-        <p:spPr>
-          <a:xfrm>
-            <a:off x="6400800" y="2752344"/>
-            <a:ext cx="1645920" cy="365760"/>
-          </a:xfrm>
-          <a:prstGeom prst="rect">
-            <a:avLst/>
-          </a:prstGeom>
-          <a:noFill/>
-        </p:spPr>
-        <p:txBody>
-          <a:bodyPr wrap="square" lIns="0" rIns="0" tIns="0" bIns="0">
-            <a:spAutoFit/>
-          </a:bodyPr>
-          <a:lstStyle/>
-          <a:p>
-            <a:pPr algn="r">
-              <a:lnSpc>
-                <a:spcPts val="1920"/>
-              </a:lnSpc>
-            </a:pPr>
-            <a:r>
-              <a:rPr sz="1500" b="0" i="0">
-                <a:solidFill>
-                  <a:srgbClr val="212529"/>
-                </a:solidFill>
-                <a:latin typeface="Garamond"/>
-              </a:rPr>
-              <a:t>25.9</a:t>
-            </a:r>
-          </a:p>
-        </p:txBody>
-      </p:sp>
-      <p:sp>
-        <p:nvSpPr>
-          <p:cNvPr id="22" name="TextBox 21"/>
-          <p:cNvSpPr txBox="1"/>
-          <p:nvPr/>
-        </p:nvSpPr>
-        <p:spPr>
-          <a:xfrm>
-            <a:off x="8138160" y="2752344"/>
-            <a:ext cx="1737360" cy="365760"/>
-          </a:xfrm>
-          <a:prstGeom prst="rect">
-            <a:avLst/>
-          </a:prstGeom>
-          <a:noFill/>
-        </p:spPr>
-        <p:txBody>
-          <a:bodyPr wrap="square" lIns="0" rIns="0" tIns="0" bIns="0">
-            <a:spAutoFit/>
-          </a:bodyPr>
-          <a:lstStyle/>
-          <a:p>
-            <a:pPr algn="r">
-              <a:lnSpc>
-                <a:spcPts val="1920"/>
-              </a:lnSpc>
-            </a:pPr>
-            <a:r>
-              <a:rPr sz="1500" b="0" i="0">
-                <a:solidFill>
-                  <a:srgbClr val="212529"/>
-                </a:solidFill>
-                <a:latin typeface="Garamond"/>
-              </a:rPr>
-              <a:t>50.8</a:t>
-            </a:r>
-          </a:p>
-        </p:txBody>
-      </p:sp>
-      <p:sp>
-        <p:nvSpPr>
-          <p:cNvPr id="23" name="TextBox 22"/>
-          <p:cNvSpPr txBox="1"/>
-          <p:nvPr/>
-        </p:nvSpPr>
-        <p:spPr>
-          <a:xfrm>
-            <a:off x="9966960" y="2752344"/>
-            <a:ext cx="1554480" cy="365760"/>
-          </a:xfrm>
-          <a:prstGeom prst="rect">
-            <a:avLst/>
-          </a:prstGeom>
-          <a:noFill/>
-        </p:spPr>
-        <p:txBody>
-          <a:bodyPr wrap="square" lIns="0" rIns="0" tIns="0" bIns="0">
-            <a:spAutoFit/>
-          </a:bodyPr>
-          <a:lstStyle/>
-          <a:p>
-            <a:pPr algn="r">
-              <a:lnSpc>
-                <a:spcPts val="1920"/>
-              </a:lnSpc>
-            </a:pPr>
-            <a:r>
-              <a:rPr sz="1500" b="0" i="0">
-                <a:solidFill>
-                  <a:srgbClr val="212529"/>
-                </a:solidFill>
-                <a:latin typeface="Garamond"/>
-              </a:rPr>
-              <a:t>67.8</a:t>
-            </a:r>
-          </a:p>
-        </p:txBody>
-      </p:sp>
-      <p:sp>
-        <p:nvSpPr>
-          <p:cNvPr id="24" name="TextBox 23"/>
-          <p:cNvSpPr txBox="1"/>
-          <p:nvPr/>
-        </p:nvSpPr>
-        <p:spPr>
-          <a:xfrm>
-            <a:off x="822960" y="3118103"/>
-            <a:ext cx="3657600" cy="365760"/>
-          </a:xfrm>
-          <a:prstGeom prst="rect">
-            <a:avLst/>
-          </a:prstGeom>
-          <a:noFill/>
-        </p:spPr>
-        <p:txBody>
-          <a:bodyPr wrap="square" lIns="0" rIns="0" tIns="0" bIns="0">
-            <a:spAutoFit/>
-          </a:bodyPr>
-          <a:lstStyle/>
-          <a:p>
-            <a:pPr algn="l">
-              <a:lnSpc>
-                <a:spcPts val="1920"/>
-              </a:lnSpc>
-            </a:pPr>
-            <a:r>
-              <a:rPr sz="1500" b="0" i="0">
-                <a:solidFill>
-                  <a:srgbClr val="212529"/>
-                </a:solidFill>
-                <a:latin typeface="Garamond"/>
-              </a:rPr>
-              <a:t>Public sector (%)</a:t>
-            </a:r>
-          </a:p>
-        </p:txBody>
-      </p:sp>
-      <p:sp>
-        <p:nvSpPr>
-          <p:cNvPr id="25" name="TextBox 24"/>
-          <p:cNvSpPr txBox="1"/>
-          <p:nvPr/>
-        </p:nvSpPr>
-        <p:spPr>
-          <a:xfrm>
-            <a:off x="4663440" y="3118103"/>
-            <a:ext cx="1645920" cy="365760"/>
-          </a:xfrm>
-          <a:prstGeom prst="rect">
-            <a:avLst/>
-          </a:prstGeom>
-          <a:noFill/>
-        </p:spPr>
-        <p:txBody>
-          <a:bodyPr wrap="square" lIns="0" rIns="0" tIns="0" bIns="0">
-            <a:spAutoFit/>
-          </a:bodyPr>
-          <a:lstStyle/>
-          <a:p>
-            <a:pPr algn="r">
-              <a:lnSpc>
-                <a:spcPts val="1920"/>
-              </a:lnSpc>
-            </a:pPr>
-            <a:r>
-              <a:rPr sz="1500" b="0" i="0">
-                <a:solidFill>
-                  <a:srgbClr val="212529"/>
-                </a:solidFill>
-                <a:latin typeface="Garamond"/>
-              </a:rPr>
-              <a:t>70.2</a:t>
-            </a:r>
-          </a:p>
-        </p:txBody>
-      </p:sp>
-      <p:sp>
-        <p:nvSpPr>
-          <p:cNvPr id="26" name="TextBox 25"/>
-          <p:cNvSpPr txBox="1"/>
-          <p:nvPr/>
-        </p:nvSpPr>
-        <p:spPr>
-          <a:xfrm>
-            <a:off x="6400800" y="3118103"/>
-            <a:ext cx="1645920" cy="365760"/>
-          </a:xfrm>
-          <a:prstGeom prst="rect">
-            <a:avLst/>
-          </a:prstGeom>
-          <a:noFill/>
-        </p:spPr>
-        <p:txBody>
-          <a:bodyPr wrap="square" lIns="0" rIns="0" tIns="0" bIns="0">
-            <a:spAutoFit/>
-          </a:bodyPr>
-          <a:lstStyle/>
-          <a:p>
-            <a:pPr algn="r">
-              <a:lnSpc>
-                <a:spcPts val="1920"/>
-              </a:lnSpc>
-            </a:pPr>
-            <a:r>
-              <a:rPr sz="1500" b="0" i="0">
-                <a:solidFill>
-                  <a:srgbClr val="212529"/>
-                </a:solidFill>
-                <a:latin typeface="Garamond"/>
-              </a:rPr>
-              <a:t>12.3</a:t>
-            </a:r>
-          </a:p>
-        </p:txBody>
-      </p:sp>
-      <p:sp>
-        <p:nvSpPr>
-          <p:cNvPr id="27" name="TextBox 26"/>
-          <p:cNvSpPr txBox="1"/>
-          <p:nvPr/>
-        </p:nvSpPr>
-        <p:spPr>
-          <a:xfrm>
-            <a:off x="8138160" y="3118103"/>
-            <a:ext cx="1737360" cy="365760"/>
-          </a:xfrm>
-          <a:prstGeom prst="rect">
-            <a:avLst/>
-          </a:prstGeom>
-          <a:noFill/>
-        </p:spPr>
-        <p:txBody>
-          <a:bodyPr wrap="square" lIns="0" rIns="0" tIns="0" bIns="0">
-            <a:spAutoFit/>
-          </a:bodyPr>
-          <a:lstStyle/>
-          <a:p>
-            <a:pPr algn="r">
-              <a:lnSpc>
-                <a:spcPts val="1920"/>
-              </a:lnSpc>
-            </a:pPr>
-            <a:r>
-              <a:rPr sz="1500" b="0" i="0">
-                <a:solidFill>
-                  <a:srgbClr val="212529"/>
-                </a:solidFill>
-                <a:latin typeface="Garamond"/>
-              </a:rPr>
-              <a:t>43.1</a:t>
-            </a:r>
-          </a:p>
-        </p:txBody>
-      </p:sp>
-      <p:sp>
-        <p:nvSpPr>
-          <p:cNvPr id="28" name="TextBox 27"/>
-          <p:cNvSpPr txBox="1"/>
-          <p:nvPr/>
-        </p:nvSpPr>
-        <p:spPr>
-          <a:xfrm>
-            <a:off x="9966960" y="3118103"/>
-            <a:ext cx="1554480" cy="365760"/>
-          </a:xfrm>
-          <a:prstGeom prst="rect">
-            <a:avLst/>
-          </a:prstGeom>
-          <a:noFill/>
-        </p:spPr>
-        <p:txBody>
-          <a:bodyPr wrap="square" lIns="0" rIns="0" tIns="0" bIns="0">
-            <a:spAutoFit/>
-          </a:bodyPr>
-          <a:lstStyle/>
-          <a:p>
-            <a:pPr algn="r">
-              <a:lnSpc>
-                <a:spcPts val="1920"/>
-              </a:lnSpc>
-            </a:pPr>
-            <a:r>
-              <a:rPr sz="1500" b="0" i="0">
-                <a:solidFill>
-                  <a:srgbClr val="212529"/>
-                </a:solidFill>
-                <a:latin typeface="Garamond"/>
-              </a:rPr>
-              <a:t>36.7</a:t>
-            </a:r>
-          </a:p>
-        </p:txBody>
-      </p:sp>
-      <p:sp>
-        <p:nvSpPr>
-          <p:cNvPr id="29" name="TextBox 28"/>
-          <p:cNvSpPr txBox="1"/>
-          <p:nvPr/>
-        </p:nvSpPr>
-        <p:spPr>
-          <a:xfrm>
-            <a:off x="822960" y="3483863"/>
-            <a:ext cx="3657600" cy="365760"/>
-          </a:xfrm>
-          <a:prstGeom prst="rect">
-            <a:avLst/>
-          </a:prstGeom>
-          <a:noFill/>
-        </p:spPr>
-        <p:txBody>
-          <a:bodyPr wrap="square" lIns="0" rIns="0" tIns="0" bIns="0">
-            <a:spAutoFit/>
-          </a:bodyPr>
-          <a:lstStyle/>
-          <a:p>
-            <a:pPr algn="l">
-              <a:lnSpc>
-                <a:spcPts val="1920"/>
-              </a:lnSpc>
-            </a:pPr>
-            <a:r>
-              <a:rPr sz="1500" b="0" i="0">
-                <a:solidFill>
-                  <a:srgbClr val="212529"/>
-                </a:solidFill>
-                <a:latin typeface="Garamond"/>
-              </a:rPr>
-              <a:t>Weeks worked</a:t>
-            </a:r>
-          </a:p>
-        </p:txBody>
-      </p:sp>
-      <p:sp>
-        <p:nvSpPr>
-          <p:cNvPr id="30" name="TextBox 29"/>
-          <p:cNvSpPr txBox="1"/>
-          <p:nvPr/>
-        </p:nvSpPr>
-        <p:spPr>
-          <a:xfrm>
-            <a:off x="4663440" y="3483863"/>
-            <a:ext cx="1645920" cy="365760"/>
-          </a:xfrm>
-          <a:prstGeom prst="rect">
-            <a:avLst/>
-          </a:prstGeom>
-          <a:noFill/>
-        </p:spPr>
-        <p:txBody>
-          <a:bodyPr wrap="square" lIns="0" rIns="0" tIns="0" bIns="0">
-            <a:spAutoFit/>
-          </a:bodyPr>
-          <a:lstStyle/>
-          <a:p>
-            <a:pPr algn="r">
-              <a:lnSpc>
-                <a:spcPts val="1920"/>
-              </a:lnSpc>
-            </a:pPr>
-            <a:r>
-              <a:rPr sz="1500" b="0" i="0">
-                <a:solidFill>
-                  <a:srgbClr val="212529"/>
-                </a:solidFill>
-                <a:latin typeface="Garamond"/>
-              </a:rPr>
-              <a:t>46.6</a:t>
-            </a:r>
-          </a:p>
-        </p:txBody>
-      </p:sp>
-      <p:sp>
-        <p:nvSpPr>
-          <p:cNvPr id="31" name="TextBox 30"/>
-          <p:cNvSpPr txBox="1"/>
-          <p:nvPr/>
-        </p:nvSpPr>
-        <p:spPr>
-          <a:xfrm>
-            <a:off x="6400800" y="3483863"/>
-            <a:ext cx="1645920" cy="365760"/>
-          </a:xfrm>
-          <a:prstGeom prst="rect">
-            <a:avLst/>
-          </a:prstGeom>
-          <a:noFill/>
-        </p:spPr>
-        <p:txBody>
-          <a:bodyPr wrap="square" lIns="0" rIns="0" tIns="0" bIns="0">
-            <a:spAutoFit/>
-          </a:bodyPr>
-          <a:lstStyle/>
-          <a:p>
-            <a:pPr algn="r">
-              <a:lnSpc>
-                <a:spcPts val="1920"/>
-              </a:lnSpc>
-            </a:pPr>
-            <a:r>
-              <a:rPr sz="1500" b="0" i="0">
-                <a:solidFill>
-                  <a:srgbClr val="212529"/>
-                </a:solidFill>
-                <a:latin typeface="Garamond"/>
-              </a:rPr>
-              <a:t>49.3</a:t>
-            </a:r>
-          </a:p>
-        </p:txBody>
-      </p:sp>
-      <p:sp>
-        <p:nvSpPr>
-          <p:cNvPr id="32" name="TextBox 31"/>
-          <p:cNvSpPr txBox="1"/>
-          <p:nvPr/>
-        </p:nvSpPr>
-        <p:spPr>
-          <a:xfrm>
-            <a:off x="8138160" y="3483863"/>
-            <a:ext cx="1737360" cy="365760"/>
-          </a:xfrm>
-          <a:prstGeom prst="rect">
-            <a:avLst/>
-          </a:prstGeom>
-          <a:noFill/>
-        </p:spPr>
-        <p:txBody>
-          <a:bodyPr wrap="square" lIns="0" rIns="0" tIns="0" bIns="0">
-            <a:spAutoFit/>
-          </a:bodyPr>
-          <a:lstStyle/>
-          <a:p>
-            <a:pPr algn="r">
-              <a:lnSpc>
-                <a:spcPts val="1920"/>
-              </a:lnSpc>
-            </a:pPr>
-            <a:r>
-              <a:rPr sz="1500" b="0" i="0">
-                <a:solidFill>
-                  <a:srgbClr val="212529"/>
-                </a:solidFill>
-                <a:latin typeface="Garamond"/>
-              </a:rPr>
-              <a:t>49.6</a:t>
-            </a:r>
-          </a:p>
-        </p:txBody>
-      </p:sp>
-      <p:sp>
-        <p:nvSpPr>
-          <p:cNvPr id="33" name="TextBox 32"/>
-          <p:cNvSpPr txBox="1"/>
-          <p:nvPr/>
-        </p:nvSpPr>
-        <p:spPr>
-          <a:xfrm>
-            <a:off x="9966960" y="3483863"/>
-            <a:ext cx="1554480" cy="365760"/>
-          </a:xfrm>
-          <a:prstGeom prst="rect">
-            <a:avLst/>
-          </a:prstGeom>
-          <a:noFill/>
-        </p:spPr>
-        <p:txBody>
-          <a:bodyPr wrap="square" lIns="0" rIns="0" tIns="0" bIns="0">
-            <a:spAutoFit/>
-          </a:bodyPr>
-          <a:lstStyle/>
-          <a:p>
-            <a:pPr algn="r">
-              <a:lnSpc>
-                <a:spcPts val="1920"/>
-              </a:lnSpc>
-            </a:pPr>
-            <a:r>
-              <a:rPr sz="1500" b="0" i="0">
-                <a:solidFill>
-                  <a:srgbClr val="212529"/>
-                </a:solidFill>
-                <a:latin typeface="Garamond"/>
-              </a:rPr>
-              <a:t>48.5</a:t>
-            </a:r>
-          </a:p>
-        </p:txBody>
-      </p:sp>
-      <p:sp>
-        <p:nvSpPr>
-          <p:cNvPr id="34" name="TextBox 33"/>
-          <p:cNvSpPr txBox="1"/>
-          <p:nvPr/>
-        </p:nvSpPr>
-        <p:spPr>
-          <a:xfrm>
-            <a:off x="822960" y="3849624"/>
-            <a:ext cx="3657600" cy="365760"/>
-          </a:xfrm>
-          <a:prstGeom prst="rect">
-            <a:avLst/>
-          </a:prstGeom>
-          <a:noFill/>
-        </p:spPr>
-        <p:txBody>
-          <a:bodyPr wrap="square" lIns="0" rIns="0" tIns="0" bIns="0">
-            <a:spAutoFit/>
-          </a:bodyPr>
-          <a:lstStyle/>
-          <a:p>
-            <a:pPr algn="l">
-              <a:lnSpc>
-                <a:spcPts val="1920"/>
-              </a:lnSpc>
-            </a:pPr>
-            <a:r>
-              <a:rPr sz="1500" b="0" i="0">
-                <a:solidFill>
-                  <a:srgbClr val="212529"/>
-                </a:solidFill>
-                <a:latin typeface="Garamond"/>
-              </a:rPr>
-              <a:t>Median annual wage ($)</a:t>
-            </a:r>
-          </a:p>
-        </p:txBody>
-      </p:sp>
-      <p:sp>
-        <p:nvSpPr>
-          <p:cNvPr id="35" name="TextBox 34"/>
-          <p:cNvSpPr txBox="1"/>
-          <p:nvPr/>
-        </p:nvSpPr>
-        <p:spPr>
-          <a:xfrm>
-            <a:off x="4663440" y="3849624"/>
-            <a:ext cx="1645920" cy="365760"/>
-          </a:xfrm>
-          <a:prstGeom prst="rect">
-            <a:avLst/>
-          </a:prstGeom>
-          <a:noFill/>
-        </p:spPr>
-        <p:txBody>
-          <a:bodyPr wrap="square" lIns="0" rIns="0" tIns="0" bIns="0">
-            <a:spAutoFit/>
-          </a:bodyPr>
-          <a:lstStyle/>
-          <a:p>
-            <a:pPr algn="r">
-              <a:lnSpc>
-                <a:spcPts val="1920"/>
-              </a:lnSpc>
-            </a:pPr>
-            <a:r>
-              <a:rPr sz="1500" b="0" i="0">
-                <a:solidFill>
-                  <a:srgbClr val="212529"/>
-                </a:solidFill>
-                <a:latin typeface="Garamond"/>
-              </a:rPr>
-              <a:t>56,000</a:t>
-            </a:r>
-          </a:p>
-        </p:txBody>
-      </p:sp>
-      <p:sp>
-        <p:nvSpPr>
-          <p:cNvPr id="36" name="TextBox 35"/>
-          <p:cNvSpPr txBox="1"/>
-          <p:nvPr/>
-        </p:nvSpPr>
-        <p:spPr>
-          <a:xfrm>
-            <a:off x="6400800" y="3849624"/>
-            <a:ext cx="1645920" cy="365760"/>
-          </a:xfrm>
-          <a:prstGeom prst="rect">
-            <a:avLst/>
-          </a:prstGeom>
-          <a:noFill/>
-        </p:spPr>
-        <p:txBody>
-          <a:bodyPr wrap="square" lIns="0" rIns="0" tIns="0" bIns="0">
-            <a:spAutoFit/>
-          </a:bodyPr>
-          <a:lstStyle/>
-          <a:p>
-            <a:pPr algn="r">
-              <a:lnSpc>
-                <a:spcPts val="1920"/>
-              </a:lnSpc>
-            </a:pPr>
-            <a:r>
-              <a:rPr sz="1500" b="0" i="0">
-                <a:solidFill>
-                  <a:srgbClr val="212529"/>
-                </a:solidFill>
-                <a:latin typeface="Garamond"/>
-              </a:rPr>
-              <a:t>80,000</a:t>
-            </a:r>
-          </a:p>
-        </p:txBody>
-      </p:sp>
-      <p:sp>
-        <p:nvSpPr>
-          <p:cNvPr id="37" name="TextBox 36"/>
-          <p:cNvSpPr txBox="1"/>
-          <p:nvPr/>
-        </p:nvSpPr>
-        <p:spPr>
-          <a:xfrm>
-            <a:off x="8138160" y="3849624"/>
-            <a:ext cx="1737360" cy="365760"/>
-          </a:xfrm>
-          <a:prstGeom prst="rect">
-            <a:avLst/>
-          </a:prstGeom>
-          <a:noFill/>
-        </p:spPr>
-        <p:txBody>
-          <a:bodyPr wrap="square" lIns="0" rIns="0" tIns="0" bIns="0">
-            <a:spAutoFit/>
-          </a:bodyPr>
-          <a:lstStyle/>
-          <a:p>
-            <a:pPr algn="r">
-              <a:lnSpc>
-                <a:spcPts val="1920"/>
-              </a:lnSpc>
-            </a:pPr>
-            <a:r>
-              <a:rPr sz="1500" b="0" i="0">
-                <a:solidFill>
-                  <a:srgbClr val="212529"/>
-                </a:solidFill>
-                <a:latin typeface="Garamond"/>
-              </a:rPr>
-              <a:t>57,000</a:t>
-            </a:r>
-          </a:p>
-        </p:txBody>
-      </p:sp>
-      <p:sp>
-        <p:nvSpPr>
-          <p:cNvPr id="38" name="TextBox 37"/>
-          <p:cNvSpPr txBox="1"/>
-          <p:nvPr/>
-        </p:nvSpPr>
-        <p:spPr>
-          <a:xfrm>
-            <a:off x="9966960" y="3849624"/>
-            <a:ext cx="1554480" cy="365760"/>
-          </a:xfrm>
-          <a:prstGeom prst="rect">
-            <a:avLst/>
-          </a:prstGeom>
-          <a:noFill/>
-        </p:spPr>
-        <p:txBody>
-          <a:bodyPr wrap="square" lIns="0" rIns="0" tIns="0" bIns="0">
-            <a:spAutoFit/>
-          </a:bodyPr>
-          <a:lstStyle/>
-          <a:p>
-            <a:pPr algn="r">
-              <a:lnSpc>
-                <a:spcPts val="1920"/>
-              </a:lnSpc>
-            </a:pPr>
-            <a:r>
-              <a:rPr sz="1500" b="0" i="0">
-                <a:solidFill>
-                  <a:srgbClr val="212529"/>
-                </a:solidFill>
-                <a:latin typeface="Garamond"/>
-              </a:rPr>
-              <a:t>55,000</a:t>
-            </a:r>
-          </a:p>
-        </p:txBody>
-      </p:sp>
-      <p:cxnSp>
-        <p:nvCxnSpPr>
-          <p:cNvPr id="39" name="Connector 38"/>
-          <p:cNvCxnSpPr/>
-          <p:nvPr/>
-        </p:nvCxnSpPr>
-        <p:spPr>
-          <a:xfrm>
-            <a:off x="822960" y="4233672"/>
-            <a:ext cx="10698480" cy="0"/>
-          </a:xfrm>
-          <a:prstGeom prst="line">
-            <a:avLst/>
-          </a:prstGeom>
-          <a:ln w="8890">
-            <a:solidFill>
-              <a:srgbClr val="212529"/>
-            </a:solidFill>
-          </a:ln>
-          <a:effectLst/>
-        </p:spPr>
-        <p:style>
-          <a:lnRef idx="2">
-            <a:schemeClr val="accent1"/>
-          </a:lnRef>
-          <a:fillRef idx="0">
-            <a:schemeClr val="accent1"/>
-          </a:fillRef>
-          <a:effectRef idx="1">
-            <a:schemeClr val="accent1"/>
-          </a:effectRef>
-          <a:fontRef idx="minor">
-            <a:schemeClr val="tx1"/>
-          </a:fontRef>
-        </p:style>
-      </p:cxnSp>
-      <p:sp>
-        <p:nvSpPr>
-          <p:cNvPr id="40" name="TextBox 39"/>
-          <p:cNvSpPr txBox="1"/>
-          <p:nvPr/>
-        </p:nvSpPr>
-        <p:spPr>
-          <a:xfrm>
-            <a:off x="822960" y="4343400"/>
-            <a:ext cx="3657600" cy="365760"/>
-          </a:xfrm>
-          <a:prstGeom prst="rect">
-            <a:avLst/>
-          </a:prstGeom>
-          <a:noFill/>
-        </p:spPr>
-        <p:txBody>
-          <a:bodyPr wrap="square" lIns="0" rIns="0" tIns="0" bIns="0">
-            <a:spAutoFit/>
-          </a:bodyPr>
-          <a:lstStyle/>
-          <a:p>
-            <a:pPr algn="l">
-              <a:lnSpc>
-                <a:spcPts val="1920"/>
-              </a:lnSpc>
-            </a:pPr>
-            <a:r>
-              <a:rPr sz="1500" b="0" i="0">
-                <a:solidFill>
-                  <a:srgbClr val="212529"/>
-                </a:solidFill>
-                <a:latin typeface="Garamond"/>
-              </a:rPr>
-              <a:t>Observations</a:t>
-            </a:r>
-          </a:p>
-        </p:txBody>
-      </p:sp>
-      <p:sp>
-        <p:nvSpPr>
-          <p:cNvPr id="41" name="TextBox 40"/>
-          <p:cNvSpPr txBox="1"/>
-          <p:nvPr/>
-        </p:nvSpPr>
-        <p:spPr>
-          <a:xfrm>
-            <a:off x="4663440" y="4343400"/>
-            <a:ext cx="1645920" cy="365760"/>
-          </a:xfrm>
-          <a:prstGeom prst="rect">
-            <a:avLst/>
-          </a:prstGeom>
-          <a:noFill/>
-        </p:spPr>
-        <p:txBody>
-          <a:bodyPr wrap="square" lIns="0" rIns="0" tIns="0" bIns="0">
-            <a:spAutoFit/>
-          </a:bodyPr>
-          <a:lstStyle/>
-          <a:p>
-            <a:pPr algn="r">
-              <a:lnSpc>
-                <a:spcPts val="1920"/>
-              </a:lnSpc>
-            </a:pPr>
-            <a:r>
-              <a:rPr sz="1500" b="0" i="0">
-                <a:solidFill>
-                  <a:srgbClr val="212529"/>
-                </a:solidFill>
-                <a:latin typeface="Garamond"/>
-              </a:rPr>
-              <a:t>28,932</a:t>
-            </a:r>
-          </a:p>
-        </p:txBody>
-      </p:sp>
-      <p:sp>
-        <p:nvSpPr>
-          <p:cNvPr id="42" name="TextBox 41"/>
-          <p:cNvSpPr txBox="1"/>
-          <p:nvPr/>
-        </p:nvSpPr>
-        <p:spPr>
-          <a:xfrm>
-            <a:off x="6400800" y="4343400"/>
-            <a:ext cx="1645920" cy="365760"/>
-          </a:xfrm>
-          <a:prstGeom prst="rect">
-            <a:avLst/>
-          </a:prstGeom>
-          <a:noFill/>
-        </p:spPr>
-        <p:txBody>
-          <a:bodyPr wrap="square" lIns="0" rIns="0" tIns="0" bIns="0">
-            <a:spAutoFit/>
-          </a:bodyPr>
-          <a:lstStyle/>
-          <a:p>
-            <a:pPr algn="r">
-              <a:lnSpc>
-                <a:spcPts val="1920"/>
-              </a:lnSpc>
-            </a:pPr>
-            <a:r>
-              <a:rPr sz="1500" b="0" i="0">
-                <a:solidFill>
-                  <a:srgbClr val="212529"/>
-                </a:solidFill>
-                <a:latin typeface="Garamond"/>
-              </a:rPr>
-              <a:t>13,107</a:t>
-            </a:r>
-          </a:p>
-        </p:txBody>
-      </p:sp>
-      <p:sp>
-        <p:nvSpPr>
-          <p:cNvPr id="43" name="TextBox 42"/>
-          <p:cNvSpPr txBox="1"/>
-          <p:nvPr/>
-        </p:nvSpPr>
-        <p:spPr>
-          <a:xfrm>
-            <a:off x="8138160" y="4343400"/>
-            <a:ext cx="1737360" cy="365760"/>
-          </a:xfrm>
-          <a:prstGeom prst="rect">
-            <a:avLst/>
-          </a:prstGeom>
-          <a:noFill/>
-        </p:spPr>
-        <p:txBody>
-          <a:bodyPr wrap="square" lIns="0" rIns="0" tIns="0" bIns="0">
-            <a:spAutoFit/>
-          </a:bodyPr>
-          <a:lstStyle/>
-          <a:p>
-            <a:pPr algn="r">
-              <a:lnSpc>
-                <a:spcPts val="1920"/>
-              </a:lnSpc>
-            </a:pPr>
-            <a:r>
-              <a:rPr sz="1500" b="0" i="0">
-                <a:solidFill>
-                  <a:srgbClr val="212529"/>
-                </a:solidFill>
-                <a:latin typeface="Garamond"/>
-              </a:rPr>
-              <a:t>3,407</a:t>
-            </a:r>
-          </a:p>
-        </p:txBody>
-      </p:sp>
-      <p:sp>
-        <p:nvSpPr>
-          <p:cNvPr id="44" name="TextBox 43"/>
-          <p:cNvSpPr txBox="1"/>
-          <p:nvPr/>
-        </p:nvSpPr>
-        <p:spPr>
-          <a:xfrm>
-            <a:off x="9966960" y="4343400"/>
-            <a:ext cx="1554480" cy="365760"/>
-          </a:xfrm>
-          <a:prstGeom prst="rect">
-            <a:avLst/>
-          </a:prstGeom>
-          <a:noFill/>
-        </p:spPr>
-        <p:txBody>
-          <a:bodyPr wrap="square" lIns="0" rIns="0" tIns="0" bIns="0">
-            <a:spAutoFit/>
-          </a:bodyPr>
-          <a:lstStyle/>
-          <a:p>
-            <a:pPr algn="r">
-              <a:lnSpc>
-                <a:spcPts val="1920"/>
-              </a:lnSpc>
-            </a:pPr>
-            <a:r>
-              <a:rPr sz="1500" b="0" i="0">
-                <a:solidFill>
-                  <a:srgbClr val="212529"/>
-                </a:solidFill>
-                <a:latin typeface="Garamond"/>
-              </a:rPr>
-              <a:t>3,962</a:t>
-            </a:r>
-          </a:p>
-        </p:txBody>
-      </p:sp>
-      <p:cxnSp>
-        <p:nvCxnSpPr>
-          <p:cNvPr id="45" name="Connector 44"/>
-          <p:cNvCxnSpPr/>
-          <p:nvPr/>
-        </p:nvCxnSpPr>
-        <p:spPr>
-          <a:xfrm>
-            <a:off x="822960" y="4745736"/>
-            <a:ext cx="10698480" cy="0"/>
-          </a:xfrm>
-          <a:prstGeom prst="line">
-            <a:avLst/>
-          </a:prstGeom>
-          <a:ln w="16510">
-            <a:solidFill>
-              <a:srgbClr val="212529"/>
-            </a:solidFill>
-          </a:ln>
-          <a:effectLst/>
-        </p:spPr>
-        <p:style>
-          <a:lnRef idx="2">
-            <a:schemeClr val="accent1"/>
-          </a:lnRef>
-          <a:fillRef idx="0">
-            <a:schemeClr val="accent1"/>
-          </a:fillRef>
-          <a:effectRef idx="1">
-            <a:schemeClr val="accent1"/>
-          </a:effectRef>
-          <a:fontRef idx="minor">
-            <a:schemeClr val="tx1"/>
-          </a:fontRef>
-        </p:style>
-      </p:cxnSp>
-      <p:sp>
-        <p:nvSpPr>
-          <p:cNvPr id="46" name="TextBox 45"/>
-          <p:cNvSpPr txBox="1"/>
-          <p:nvPr/>
-        </p:nvSpPr>
-        <p:spPr>
-          <a:xfrm>
-            <a:off x="822960" y="4910328"/>
-            <a:ext cx="10789920" cy="365760"/>
-          </a:xfrm>
-          <a:prstGeom prst="rect">
-            <a:avLst/>
-          </a:prstGeom>
-          <a:noFill/>
-        </p:spPr>
-        <p:txBody>
-          <a:bodyPr wrap="square" lIns="0" rIns="0" tIns="0" bIns="0">
-            <a:spAutoFit/>
-          </a:bodyPr>
-          <a:lstStyle/>
-          <a:p>
-            <a:pPr algn="l">
-              <a:lnSpc>
-                <a:spcPts val="1600"/>
-              </a:lnSpc>
-            </a:pPr>
-            <a:r>
-              <a:rPr sz="1250" b="0" i="1">
-                <a:solidFill>
-                  <a:srgbClr val="6B7480"/>
-                </a:solidFill>
-                <a:latin typeface="Garamond"/>
-              </a:rPr>
-              <a:t>College graduates, pooled 2015–2024, weighted; wages from 2020–2024.</a:t>
-            </a:r>
-          </a:p>
-        </p:txBody>
-      </p:sp>
-      <p:sp>
-        <p:nvSpPr>
-          <p:cNvPr id="47" name="TextBox 46"/>
-          <p:cNvSpPr txBox="1"/>
-          <p:nvPr/>
-        </p:nvSpPr>
-        <p:spPr>
-          <a:xfrm>
-            <a:off x="822960" y="5897880"/>
-            <a:ext cx="10789920" cy="822960"/>
-          </a:xfrm>
-          <a:prstGeom prst="rect">
-            <a:avLst/>
-          </a:prstGeom>
-          <a:noFill/>
-        </p:spPr>
-        <p:txBody>
-          <a:bodyPr wrap="square" lIns="0" rIns="0" tIns="0" bIns="0">
-            <a:spAutoFit/>
-          </a:bodyPr>
-          <a:lstStyle/>
-          <a:p>
-            <a:pPr algn="l">
-              <a:lnSpc>
-                <a:spcPts val="1855"/>
-              </a:lnSpc>
-            </a:pPr>
-            <a:r>
-              <a:rPr sz="1450" b="1" i="0">
-                <a:solidFill>
-                  <a:srgbClr val="102D5E"/>
-                </a:solidFill>
-                <a:latin typeface="Garamond"/>
-              </a:rPr>
-              <a:t>Key message.  </a:t>
-            </a:r>
-            <a:r>
-              <a:rPr sz="1450" b="0" i="0">
-                <a:solidFill>
-                  <a:srgbClr val="212529"/>
-                </a:solidFill>
-                <a:latin typeface="Garamond"/>
-              </a:rPr>
-              <a:t>Teaching is similar to counseling in gender and pay, and to social work in age and education. What sets teaching apart is the public sector and the shorter work year.</a:t>
-            </a:r>
-          </a:p>
-        </p:txBody>
-      </p:sp>
-    </p:spTree>
-  </p:cSld>
-  <p:clrMapOvr>
-    <a:masterClrMapping/>
-  </p:clrMapOvr>
-</p:sld>
-</file>
-
-<file path=ppt/slides/slide2.xml><?xml version="1.0" encoding="utf-8"?>
-<p:sld xmlns:a="http://schemas.openxmlformats.org/drawingml/2006/main" xmlns:p="http://schemas.openxmlformats.org/presentationml/2006/main" xmlns:r="http://schemas.openxmlformats.org/officeDocument/2006/relationships">
-  <p:cSld>
-    <p:spTree>
-      <p:nvGrpSpPr>
-        <p:cNvPr id="1" name=""/>
-        <p:cNvGrpSpPr/>
-        <p:nvPr/>
-      </p:nvGrpSpPr>
-      <p:grpSpPr/>
-      <p:sp>
-        <p:nvSpPr>
-          <p:cNvPr id="2" name="TextBox 1"/>
-          <p:cNvSpPr txBox="1"/>
-          <p:nvPr/>
-        </p:nvSpPr>
-        <p:spPr>
-          <a:xfrm>
-            <a:off x="502920" y="219456"/>
-            <a:ext cx="11247120" cy="566928"/>
-          </a:xfrm>
-          <a:prstGeom prst="rect">
-            <a:avLst/>
-          </a:prstGeom>
-          <a:noFill/>
-        </p:spPr>
-        <p:txBody>
-          <a:bodyPr wrap="square" lIns="0" rIns="0" tIns="0" bIns="0">
-            <a:spAutoFit/>
-          </a:bodyPr>
-          <a:lstStyle/>
-          <a:p>
-            <a:pPr algn="l">
-              <a:lnSpc>
-                <a:spcPts val="3584"/>
-              </a:lnSpc>
-            </a:pPr>
-            <a:r>
-              <a:rPr sz="2800" b="1" i="0">
-                <a:solidFill>
-                  <a:srgbClr val="102D5E"/>
-                </a:solidFill>
-                <a:latin typeface="Garamond"/>
-              </a:rPr>
-              <a:t>Leaving the occupation, by profession</a:t>
+              <a:t>Comparable professions</a:t>
             </a:r>
           </a:p>
         </p:txBody>
       </p:sp>
       <p:pic>
         <p:nvPicPr>
-          <p:cNvPr id="3" name="Picture 2" descr="leave_professions_deck.png"/>
+          <p:cNvPr id="3" name="Picture 2" descr="comparables_table.png"/>
           <p:cNvPicPr>
             <a:picLocks noChangeAspect="1"/>
           </p:cNvPicPr>
@@ -4953,8 +3138,8 @@
         </p:blipFill>
         <p:spPr>
           <a:xfrm>
-            <a:off x="1645920" y="1097280"/>
-            <a:ext cx="8869680" cy="4434840"/>
+            <a:off x="1188720" y="864315"/>
+            <a:ext cx="9784080" cy="4580728"/>
           </a:xfrm>
           <a:prstGeom prst="rect">
             <a:avLst/>
@@ -4969,8 +3154,8 @@
         </p:nvSpPr>
         <p:spPr>
           <a:xfrm>
-            <a:off x="822960" y="5687568"/>
-            <a:ext cx="10789920" cy="822960"/>
+            <a:off x="822960" y="5715000"/>
+            <a:ext cx="10789920" cy="731520"/>
           </a:xfrm>
           <a:prstGeom prst="rect">
             <a:avLst/>
@@ -4978,18 +3163,18 @@
           <a:noFill/>
         </p:spPr>
         <p:txBody>
-          <a:bodyPr wrap="square" lIns="0" rIns="0" tIns="0" bIns="0">
+          <a:bodyPr wrap="square">
             <a:spAutoFit/>
           </a:bodyPr>
           <a:lstStyle/>
           <a:p>
-            <a:pPr algn="l">
+            <a:pPr>
               <a:lnSpc>
                 <a:spcPts val="2048"/>
               </a:lnSpc>
             </a:pPr>
             <a:r>
-              <a:rPr sz="1600" b="1" i="0">
+              <a:rPr sz="1600" b="1">
                 <a:solidFill>
                   <a:srgbClr val="102D5E"/>
                 </a:solidFill>
@@ -4998,13 +3183,77 @@
               <a:t>Key message.  </a:t>
             </a:r>
             <a:r>
-              <a:rPr sz="1600" b="0" i="0">
+              <a:rPr sz="1600">
                 <a:solidFill>
                   <a:srgbClr val="212529"/>
                 </a:solidFill>
                 <a:latin typeface="Garamond"/>
               </a:rPr>
-              <a:t>Teachers leave at rates similar to or below the comparable professions. The distinctive part of teaching is who leaves and where they go, not how many.</a:t>
+              <a:t>Teaching is similar to nursing, social work and counseling in age and gender, and to social work in education and wages; the main difference is nurses' pay.</a:t>
+            </a:r>
+          </a:p>
+        </p:txBody>
+      </p:sp>
+      <p:sp>
+        <p:nvSpPr>
+          <p:cNvPr id="5" name="Rounded Rectangle 4">
+            <a:hlinkClick action="ppaction://hlinksldjump" r:id="rId3"/>
+          </p:cNvPr>
+          <p:cNvSpPr/>
+          <p:nvPr/>
+        </p:nvSpPr>
+        <p:spPr>
+          <a:xfrm>
+            <a:off x="11018520" y="6382512"/>
+            <a:ext cx="994867" cy="347472"/>
+          </a:xfrm>
+          <a:prstGeom prst="roundRect">
+            <a:avLst/>
+          </a:prstGeom>
+          <a:solidFill>
+            <a:srgbClr val="BED3EE"/>
+          </a:solidFill>
+          <a:ln>
+            <a:noFill/>
+          </a:ln>
+          <a:effectLst/>
+        </p:spPr>
+        <p:style>
+          <a:lnRef idx="1">
+            <a:schemeClr val="accent1"/>
+          </a:lnRef>
+          <a:fillRef idx="3">
+            <a:schemeClr val="accent1"/>
+          </a:fillRef>
+          <a:effectRef idx="2">
+            <a:schemeClr val="accent1"/>
+          </a:effectRef>
+          <a:fontRef idx="minor">
+            <a:schemeClr val="lt1"/>
+          </a:fontRef>
+        </p:style>
+        <p:txBody>
+          <a:bodyPr rtlCol="0" anchor="ctr" wrap="none" lIns="36576" rIns="36576" tIns="0" bIns="0"/>
+          <a:lstStyle/>
+          <a:p>
+            <a:pPr algn="ctr"/>
+            <a:r>
+              <a:rPr sz="1700" b="1">
+                <a:solidFill>
+                  <a:srgbClr val="102D5E"/>
+                </a:solidFill>
+                <a:latin typeface="Garamond"/>
+              </a:rPr>
+              <a:t>☞ </a:t>
+            </a:r>
+            <a:r>
+              <a:rPr sz="1350">
+                <a:solidFill>
+                  <a:srgbClr val="102D5E"/>
+                </a:solidFill>
+                <a:latin typeface="Garamond"/>
+              </a:rPr>
+              <a:t>Back</a:t>
             </a:r>
           </a:p>
         </p:txBody>

</xml_diff>